<commit_message>
Refresh product roadmap, architecture, and guides
</commit_message>
<xml_diff>
--- a/docs/MacroAtlas_User_Guide.pptx
+++ b/docs/MacroAtlas_User_Guide.pptx
@@ -3283,7 +3283,7 @@
                 </a:solidFill>
                 <a:latin typeface="Malgun Gothic"/>
               </a:rPr>
-              <a:t>2026-10-26  |  제한 범위 로컬 v1</a:t>
+              <a:t>2026-10-26  |  현재 지원 범위·17회차 시험</a:t>
             </a:r>
           </a:p>
         </p:txBody>
@@ -3387,7 +3387,7 @@
                 </a:solidFill>
                 <a:latin typeface="Malgun Gothic"/>
               </a:rPr>
-              <a:t>제한 범위 v1의 경계</a:t>
+              <a:t>현재 경계와 다음 투자</a:t>
             </a:r>
           </a:p>
         </p:txBody>
@@ -3422,7 +3422,7 @@
                 </a:solidFill>
                 <a:latin typeface="Malgun Gothic"/>
               </a:rPr>
-              <a:t>MACROATLAS  ·  제한 범위 로컬 v1  ·  10</a:t>
+              <a:t>MACROATLAS  ·  증거 범위를 지킵니다  ·  10</a:t>
             </a:r>
           </a:p>
         </p:txBody>
@@ -3543,7 +3543,7 @@
                 </a:solidFill>
                 <a:latin typeface="Malgun Gothic"/>
               </a:rPr>
-              <a:t>Gate A/B/C/D의 현재 제한 판정과 Gate E 보고서는 docs/IMPLEMENTATION_PLAN.md 및 회차 보고서를 따릅니다.</a:t>
+              <a:t>Gate A/D 통과, B/C/E 제한 범위 판정입니다. 현재 범위와 증거는 docs/IMPLEMENTATION_PLAN.md를 확인하세요.</a:t>
             </a:r>
           </a:p>
         </p:txBody>
@@ -3621,7 +3621,7 @@
                 </a:solidFill>
                 <a:latin typeface="Malgun Gothic"/>
               </a:rPr>
-              <a:t>실제 TIC/BIS source revision과 자연 provider failure → durable resume는 여전히 확인되지 않았습니다.</a:t>
+              <a:t>자연 TIC/BIS source revision 및 자연 provider failure → 같은 task 재개는 아직 관측되지 않았습니다.</a:t>
             </a:r>
           </a:p>
         </p:txBody>
@@ -3699,7 +3699,7 @@
                 </a:solidFill>
                 <a:latin typeface="Malgun Gothic"/>
               </a:rPr>
-              <a:t>BOJ direct smoke는 collector·Orchestrator 통합이나 기관 전반 지원을 뜻하지 않습니다.</a:t>
+              <a:t>대용량 trial 통과는 production 정규화 승인이 아닙니다. BIS 정식 handoff와 CSV exporter는 후속 작업입니다.</a:t>
             </a:r>
           </a:p>
         </p:txBody>
@@ -3777,7 +3777,7 @@
                 </a:solidFill>
                 <a:latin typeface="Malgun Gothic"/>
               </a:rPr>
-              <a:t>A–H 부분·미지원 경로는 자동으로 완료 처리하지 않습니다. 출처·정의·권한이 불확실하면 검토 상태를 유지합니다.</a:t>
+              <a:t>다음 순서: PR 통합 검토 → 재현 가능한 QA 경로 → BIS 대용량 handoff → 검증된 CSV 전달.</a:t>
             </a:r>
           </a:p>
         </p:txBody>
@@ -3855,7 +3855,7 @@
                 </a:solidFill>
                 <a:latin typeface="Malgun Gothic"/>
               </a:rPr>
-              <a:t>Gate E는 제한된 로컬 v1 검토입니다. 문서 승인, branch merge, 서비스 publish는 별도입니다.</a:t>
+              <a:t>일반 검색·추가 기관·자동 merge/publish는 별도 검토 대상입니다. 자연 증거는 인위적으로 만들지 않습니다.</a:t>
             </a:r>
           </a:p>
         </p:txBody>
@@ -3959,7 +3959,7 @@
                 </a:solidFill>
                 <a:latin typeface="Malgun Gothic"/>
               </a:rPr>
-              <a:t>현재 버전에서 할 수 있는 일</a:t>
+              <a:t>현재 지원 경로</a:t>
             </a:r>
           </a:p>
         </p:txBody>
@@ -3994,7 +3994,7 @@
                 </a:solidFill>
                 <a:latin typeface="Malgun Gothic"/>
               </a:rPr>
-              <a:t>MACROATLAS  ·  제한 범위 로컬 v1  ·  02</a:t>
+              <a:t>MACROATLAS  ·  지원 범위  ·  02</a:t>
             </a:r>
           </a:p>
         </p:txBody>
@@ -4158,7 +4158,7 @@
                 </a:solidFill>
                 <a:latin typeface="Malgun Gothic"/>
               </a:rPr>
-              <a:t>확인된 경로</a:t>
+              <a:t>고정 경로</a:t>
             </a:r>
           </a:p>
         </p:txBody>
@@ -4193,7 +4193,7 @@
                 </a:solidFill>
                 <a:latin typeface="Malgun Gothic"/>
               </a:rPr>
-              <a:t>World Bank WDI의 미국 GDP 고정 검증 요청을 실행하고 원본·manifest·검증 결과를 저장합니다.</a:t>
+              <a:t>World Bank USA GDP, BOJ FM08/FXERD01 한 달, TIC/BIS exact-scope file watch를 제공합니다.</a:t>
             </a:r>
           </a:p>
         </p:txBody>
@@ -4349,7 +4349,7 @@
                 </a:solidFill>
                 <a:latin typeface="Malgun Gothic"/>
               </a:rPr>
-              <a:t>BLS/Census 제한 API, 표 파일 파서, 피드백 저장·조회와 읽기 전용 반복 패턴 분석기가 있습니다.</a:t>
+              <a:t>제한된 BLS/Census Python API, 명시 파일 parser, task·feedback 이력과 읽기 전용 pattern 분석이 있습니다.</a:t>
             </a:r>
           </a:p>
         </p:txBody>
@@ -4470,7 +4470,7 @@
                 </a:solidFill>
                 <a:latin typeface="Malgun Gothic"/>
               </a:rPr>
-              <a:t>범위 제한</a:t>
+              <a:t>아직 미제공</a:t>
             </a:r>
           </a:p>
         </p:txBody>
@@ -4505,7 +4505,7 @@
                 </a:solidFill>
                 <a:latin typeface="Malgun Gothic"/>
               </a:rPr>
-              <a:t>일반 자연어 검색 CLI, 모든 기관의 end-to-end 수집, CSV/XLSX exporter, 자동 스케줄러는 없습니다.</a:t>
+              <a:t>일반 자연어·기관 전체 검색, 정식 대용량 정규화, CSV/XLSX exporter, 제품 자체 스케줄러는 없습니다.</a:t>
             </a:r>
           </a:p>
         </p:txBody>
@@ -4626,7 +4626,7 @@
                 </a:solidFill>
                 <a:latin typeface="Malgun Gothic"/>
               </a:rPr>
-              <a:t>기관 상태</a:t>
+              <a:t>증거 경계</a:t>
             </a:r>
           </a:p>
         </p:txBody>
@@ -4661,7 +4661,7 @@
                 </a:solidFill>
                 <a:latin typeface="Malgun Gothic"/>
               </a:rPr>
-              <a:t>BIS/TIC은 명시 파일 intake, BOJ는 API smoke만 확인했습니다. 부분 확인은 기관 전체 지원을 뜻하지 않습니다.</a:t>
+              <a:t>TIC/BIS 자연 개정과 자연 provider 실패 후 같은 task 재개는 미관측입니다. 제한 경로 성공을 전체 지원으로 넓히지 않습니다.</a:t>
             </a:r>
           </a:p>
         </p:txBody>
@@ -4800,7 +4800,7 @@
                 </a:solidFill>
                 <a:latin typeface="Malgun Gothic"/>
               </a:rPr>
-              <a:t>MACROATLAS  ·  제한 범위 로컬 v1  ·  03</a:t>
+              <a:t>MACROATLAS  ·  요청부터 검증까지  ·  03</a:t>
             </a:r>
           </a:p>
         </p:txBody>
@@ -6077,7 +6077,7 @@
                 </a:solidFill>
                 <a:latin typeface="Malgun Gothic"/>
               </a:rPr>
-              <a:t>대표 live 검증 명령</a:t>
+              <a:t>고정 경로 실행과 task 확인</a:t>
             </a:r>
           </a:p>
         </p:txBody>
@@ -6112,7 +6112,7 @@
                 </a:solidFill>
                 <a:latin typeface="Malgun Gothic"/>
               </a:rPr>
-              <a:t>MACROATLAS  ·  제한 범위 로컬 v1  ·  04</a:t>
+              <a:t>MACROATLAS  ·  실제 요청은 --live  ·  04</a:t>
             </a:r>
           </a:p>
         </p:txBody>
@@ -6233,7 +6233,7 @@
                 </a:solidFill>
                 <a:latin typeface="Consolas"/>
               </a:rPr>
-              <a:t>python scripts/verify_worldbank.py --live --gate-a</a:t>
+              <a:t>macroatlas collect worldbank-gdp --start-year 2020 --end-year 2022 --live</a:t>
             </a:r>
           </a:p>
         </p:txBody>
@@ -6311,7 +6311,7 @@
                 </a:solidFill>
                 <a:latin typeface="Malgun Gothic"/>
               </a:rPr>
-              <a:t>이 명령은 고정된 USA · WDI source 2 · NY.GDP.MKTP.CD · 2020–2022 요청 한 건만 실행합니다.</a:t>
+              <a:t>이 범위는 USA · WDI source 2 · NY.GDP.MKTP.CD만 수집합니다. BOJ는 FM08/FXERD01 한 달만 지원합니다.</a:t>
             </a:r>
           </a:p>
         </p:txBody>
@@ -6389,7 +6389,7 @@
                 </a:solidFill>
                 <a:latin typeface="Malgun Gothic"/>
               </a:rPr>
-              <a:t>종료 코드 0, task COMPLETED, live_path_passed=true, validation passed를 확인합니다.</a:t>
+              <a:t>요청은 네트워크 전에 task로 저장됩니다. 출력의 TASK_ID로 상태와 저장 경로를 확인하세요.</a:t>
             </a:r>
           </a:p>
         </p:txBody>
@@ -6467,7 +6467,7 @@
                 </a:solidFill>
                 <a:latin typeface="Malgun Gothic"/>
               </a:rPr>
-              <a:t>단위·빈도가 원문에서 확인되지 않으면 unknown으로 남습니다. 경고와 미검사 항목도 읽으세요.</a:t>
+              <a:t>재개는 같은 task ID를 사용합니다. Retry-After와 attempt 예산을 지키며 자동 재시도는 하지 않습니다.</a:t>
             </a:r>
           </a:p>
         </p:txBody>
@@ -6502,7 +6502,7 @@
                 </a:solidFill>
                 <a:latin typeface="Malgun Gothic"/>
               </a:rPr>
-              <a:t>자동 재시도 없음 · redirect 차단 · TLS 검증 · 5/20초 timeout · 1 MiB 응답 상한</a:t>
+              <a:t>TIC/BIS watch도 각각 한 번의 명시적 live 요청입니다. 임의 URL이나 기관은 입력할 수 없습니다.</a:t>
             </a:r>
           </a:p>
         </p:txBody>
@@ -6606,7 +6606,7 @@
                 </a:solidFill>
                 <a:latin typeface="Malgun Gothic"/>
               </a:rPr>
-              <a:t>저장 결과와 확인 위치</a:t>
+              <a:t>결과·원본·이력 확인</a:t>
             </a:r>
           </a:p>
         </p:txBody>
@@ -6641,7 +6641,7 @@
                 </a:solidFill>
                 <a:latin typeface="Malgun Gothic"/>
               </a:rPr>
-              <a:t>MACROATLAS  ·  제한 범위 로컬 v1  ·  05</a:t>
+              <a:t>MACROATLAS  ·  task에 연결된 provenance  ·  05</a:t>
             </a:r>
           </a:p>
         </p:txBody>
@@ -6840,8 +6840,8 @@
                 </a:solidFill>
                 <a:latin typeface="Malgun Gothic"/>
               </a:rPr>
-              <a:t>data/raw/worldbank/&lt;id&gt;/response.json
-요청·출처·시각·hash manifest: request.json</a:t>
+              <a:t>data/raw/&lt;source&gt;/&lt;package-id&gt;/ 아래 raw와 request manifest
+원본 hash·범위·수집 시각을 보존합니다.</a:t>
             </a:r>
           </a:p>
         </p:txBody>
@@ -6998,7 +6998,7 @@
                 <a:latin typeface="Malgun Gothic"/>
               </a:rPr>
               <a:t>data/catalog.sqlite
-Task / stage 이벤트, Gate A validation과 정규화 observation을 보관합니다.</a:t>
+Task, stage, attempt/event와 검증 상태를 보관합니다.</a:t>
             </a:r>
           </a:p>
         </p:txBody>
@@ -7154,8 +7154,8 @@
                 </a:solidFill>
                 <a:latin typeface="Malgun Gothic"/>
               </a:rPr>
-              <a:t>reports/iteration_04_live_&lt;id&gt;.json
-상태·정규화 경고·source URL·artifact id를 확인합니다.</a:t>
+              <a:t>CLI JSON 요약
+TASK_ID, 상태, 경고, artifact 저장 경로를 확인합니다.</a:t>
             </a:r>
           </a:p>
         </p:txBody>
@@ -7311,7 +7311,7 @@
                 </a:solidFill>
                 <a:latin typeface="Malgun Gothic"/>
               </a:rPr>
-              <a:t>0과 null은 다릅니다. 원본에 없는 unit/frequency를 채우거나 cross-source 동등성을 가정하지 않습니다.</a:t>
+              <a:t>0과 null은 다릅니다. 모르는 단위·주기를 추정하지 않으며 범용 CSV/XLSX 전달은 아직 없습니다.</a:t>
             </a:r>
           </a:p>
         </p:txBody>
@@ -7450,7 +7450,7 @@
                 </a:solidFill>
                 <a:latin typeface="Malgun Gothic"/>
               </a:rPr>
-              <a:t>MACROATLAS  ·  제한 범위 로컬 v1  ·  06</a:t>
+              <a:t>MACROATLAS  ·  현재 지원 범위  ·  06</a:t>
             </a:r>
           </a:p>
         </p:txBody>
@@ -8334,7 +8334,7 @@
                 </a:solidFill>
                 <a:latin typeface="Malgun Gothic"/>
               </a:rPr>
-              <a:t>MACROATLAS  ·  제한 범위 로컬 v1  ·  07</a:t>
+              <a:t>MACROATLAS  ·  현재 지원 범위  ·  07</a:t>
             </a:r>
           </a:p>
         </p:txBody>
@@ -9001,7 +9001,7 @@
                 </a:solidFill>
                 <a:latin typeface="Malgun Gothic"/>
               </a:rPr>
-              <a:t>이전 유효 결과를 덮어쓰지 않고 failed stage부터 재개합니다. 자연 provider failure와 simulated fixture 증거를 구분합니다.</a:t>
+              <a:t>같은 task에서 이력을 이어갑니다. fixture 검증과 자연 발생 provider 실패 증거는 별개입니다.</a:t>
             </a:r>
           </a:p>
         </p:txBody>
@@ -9140,7 +9140,7 @@
                 </a:solidFill>
                 <a:latin typeface="Malgun Gothic"/>
               </a:rPr>
-              <a:t>MACROATLAS  ·  제한 범위 로컬 v1  ·  08</a:t>
+              <a:t>MACROATLAS  ·  현재 지원 범위  ·  08</a:t>
             </a:r>
           </a:p>
         </p:txBody>
@@ -9495,7 +9495,7 @@
                 </a:solidFill>
                 <a:latin typeface="Malgun Gothic"/>
               </a:rPr>
-              <a:t>반복 패턴 도구는 SQLite read-only 분석입니다. 제안은 draft이며 승인·코드 수정·자동 적용을 하지 않습니다.</a:t>
+              <a:t>분석 결과는 draft 검토 후보입니다. 코드 수정·승인·자동 적용을 하지 않으며 반복 근거가 없으면 후보를 만들지 않습니다.</a:t>
             </a:r>
           </a:p>
         </p:txBody>
@@ -9712,7 +9712,7 @@
                 </a:solidFill>
                 <a:latin typeface="Malgun Gothic"/>
               </a:rPr>
-              <a:t>MACROATLAS  ·  제한 범위 로컬 v1  ·  09</a:t>
+              <a:t>기관별로 확인된 좁은 범위  ·  09</a:t>
             </a:r>
           </a:p>
         </p:txBody>
@@ -10866,7 +10866,7 @@
                 </a:solidFill>
                 <a:latin typeface="Malgun Gothic"/>
               </a:rPr>
-              <a:t>BOJ API smoke only</a:t>
+              <a:t>BOJ FXERD01 한 달 collector</a:t>
             </a:r>
           </a:p>
         </p:txBody>
@@ -11318,7 +11318,7 @@
                 </a:solidFill>
                 <a:latin typeface="Malgun Gothic"/>
               </a:rPr>
-              <a:t>PARTIAL은 그 제한 경로만 확인됐다는 뜻입니다. 남은 경로는 문서에 BLOCKED/NOT_RUN으로 표시합니다.</a:t>
+              <a:t>PARTIAL은 확인된 경로만 뜻합니다. 기관 전체 상태나 일반 지원을 의미하지 않습니다.</a:t>
             </a:r>
           </a:p>
         </p:txBody>

</xml_diff>

<commit_message>
Add verified World Bank and BOJ CSV export
</commit_message>
<xml_diff>
--- a/docs/MacroAtlas_User_Guide.pptx
+++ b/docs/MacroAtlas_User_Guide.pptx
@@ -3283,7 +3283,7 @@
                 </a:solidFill>
                 <a:latin typeface="Malgun Gothic"/>
               </a:rPr>
-              <a:t>2026-10-26  |  현재 지원 범위·17회차 시험</a:t>
+              <a:t>2026-10-26  |  현재 지원 범위·20회차 CSV 전달</a:t>
             </a:r>
           </a:p>
         </p:txBody>
@@ -3699,7 +3699,7 @@
                 </a:solidFill>
                 <a:latin typeface="Malgun Gothic"/>
               </a:rPr>
-              <a:t>대용량 trial 통과는 production 정규화 승인이 아닙니다. BIS 정식 handoff와 CSV exporter는 후속 작업입니다.</a:t>
+              <a:t>대용량 trial은 production 정규화 승인이 아닙니다. BIS flat handoff와 World Bank/BOJ CSV 전달은 각각 19·20회차에 완료했습니다.</a:t>
             </a:r>
           </a:p>
         </p:txBody>
@@ -3777,7 +3777,7 @@
                 </a:solidFill>
                 <a:latin typeface="Malgun Gothic"/>
               </a:rPr>
-              <a:t>다음 순서: PR 통합 검토 → 재현 가능한 QA 경로 → BIS 대용량 handoff → 검증된 CSV 전달.</a:t>
+              <a:t>다음 순서: 사용자 업무 흐름 검증 → 사용성·지원 범위 결정. Gate C natural evidence는 관측 이벤트 대기.</a:t>
             </a:r>
           </a:p>
         </p:txBody>
@@ -4470,7 +4470,7 @@
                 </a:solidFill>
                 <a:latin typeface="Malgun Gothic"/>
               </a:rPr>
-              <a:t>아직 미제공</a:t>
+              <a:t>미지원 범위</a:t>
             </a:r>
           </a:p>
         </p:txBody>
@@ -4505,7 +4505,7 @@
                 </a:solidFill>
                 <a:latin typeface="Malgun Gothic"/>
               </a:rPr>
-              <a:t>일반 자연어·기관 전체 검색, 정식 대용량 정규화, CSV/XLSX exporter, 제품 자체 스케줄러는 없습니다.</a:t>
+              <a:t>일반 자연어·기관 전체 검색, 정식 대용량 정규화, 범용 CSV/XLSX 변환, 제품 자체 스케줄러는 없습니다. 완료 World Bank/BOJ task는 제한 CSV export를 지원합니다.</a:t>
             </a:r>
           </a:p>
         </p:txBody>
@@ -7311,7 +7311,7 @@
                 </a:solidFill>
                 <a:latin typeface="Malgun Gothic"/>
               </a:rPr>
-              <a:t>0과 null은 다릅니다. 모르는 단위·주기를 추정하지 않으며 범용 CSV/XLSX 전달은 아직 없습니다.</a:t>
+              <a:t>0과 null은 다릅니다. 완료된 World Bank/BOJ task는 CSV로 저장할 수 있습니다. 범용 CSV/XLSX 변환은 지원하지 않습니다.</a:t>
             </a:r>
           </a:p>
         </p:txBody>

</xml_diff>

<commit_message>
Add verified World Bank and BOJ CSV export (#9)
* Add verified World Bank and BOJ CSV export

* Close SQLite connections in export tests

* Record iteration 20 integration checks
</commit_message>
<xml_diff>
--- a/docs/MacroAtlas_User_Guide.pptx
+++ b/docs/MacroAtlas_User_Guide.pptx
@@ -3283,7 +3283,7 @@
                 </a:solidFill>
                 <a:latin typeface="Malgun Gothic"/>
               </a:rPr>
-              <a:t>2026-10-26  |  현재 지원 범위·17회차 시험</a:t>
+              <a:t>2026-10-26  |  현재 지원 범위·20회차 CSV 전달</a:t>
             </a:r>
           </a:p>
         </p:txBody>
@@ -3699,7 +3699,7 @@
                 </a:solidFill>
                 <a:latin typeface="Malgun Gothic"/>
               </a:rPr>
-              <a:t>대용량 trial 통과는 production 정규화 승인이 아닙니다. BIS 정식 handoff와 CSV exporter는 후속 작업입니다.</a:t>
+              <a:t>대용량 trial은 production 정규화 승인이 아닙니다. BIS flat handoff와 World Bank/BOJ CSV 전달은 각각 19·20회차에 완료했습니다.</a:t>
             </a:r>
           </a:p>
         </p:txBody>
@@ -3777,7 +3777,7 @@
                 </a:solidFill>
                 <a:latin typeface="Malgun Gothic"/>
               </a:rPr>
-              <a:t>다음 순서: PR 통합 검토 → 재현 가능한 QA 경로 → BIS 대용량 handoff → 검증된 CSV 전달.</a:t>
+              <a:t>다음 순서: 사용자 업무 흐름 검증 → 사용성·지원 범위 결정. Gate C natural evidence는 관측 이벤트 대기.</a:t>
             </a:r>
           </a:p>
         </p:txBody>
@@ -4470,7 +4470,7 @@
                 </a:solidFill>
                 <a:latin typeface="Malgun Gothic"/>
               </a:rPr>
-              <a:t>아직 미제공</a:t>
+              <a:t>미지원 범위</a:t>
             </a:r>
           </a:p>
         </p:txBody>
@@ -4505,7 +4505,7 @@
                 </a:solidFill>
                 <a:latin typeface="Malgun Gothic"/>
               </a:rPr>
-              <a:t>일반 자연어·기관 전체 검색, 정식 대용량 정규화, CSV/XLSX exporter, 제품 자체 스케줄러는 없습니다.</a:t>
+              <a:t>일반 자연어·기관 전체 검색, 정식 대용량 정규화, 범용 CSV/XLSX 변환, 제품 자체 스케줄러는 없습니다. 완료 World Bank/BOJ task는 제한 CSV export를 지원합니다.</a:t>
             </a:r>
           </a:p>
         </p:txBody>
@@ -7311,7 +7311,7 @@
                 </a:solidFill>
                 <a:latin typeface="Malgun Gothic"/>
               </a:rPr>
-              <a:t>0과 null은 다릅니다. 모르는 단위·주기를 추정하지 않으며 범용 CSV/XLSX 전달은 아직 없습니다.</a:t>
+              <a:t>0과 null은 다릅니다. 완료된 World Bank/BOJ task는 CSV로 저장할 수 있습니다. 범용 CSV/XLSX 변환은 지원하지 않습니다.</a:t>
             </a:r>
           </a:p>
         </p:txBody>

</xml_diff>

<commit_message>
feat: forecast large non-API job durations
</commit_message>
<xml_diff>
--- a/docs/MacroAtlas_User_Guide.pptx
+++ b/docs/MacroAtlas_User_Guide.pptx
@@ -3283,7 +3283,7 @@
                 </a:solidFill>
                 <a:latin typeface="Malgun Gothic"/>
               </a:rPr>
-              <a:t>2026-10-26  |  현재 지원 범위·20회차 CSV 전달</a:t>
+              <a:t>2026-10-26  |  대용량 실행 전 시간 예측 · 20회차 CSV 전달</a:t>
             </a:r>
           </a:p>
         </p:txBody>
@@ -3699,7 +3699,7 @@
                 </a:solidFill>
                 <a:latin typeface="Malgun Gothic"/>
               </a:rPr>
-              <a:t>대용량 trial은 production 정규화 승인이 아닙니다. BIS flat handoff와 World Bank/BOJ CSV 전달은 각각 19·20회차에 완료했습니다.</a:t>
+              <a:t>22회차: 비API 대용량 qualification·BIS production 실행 전에 시간·범위를 보여줍니다. 예측은 명시 승인이나 worker 상한을 바꾸지 않습니다.</a:t>
             </a:r>
           </a:p>
         </p:txBody>
@@ -8966,7 +8966,7 @@
                 </a:solidFill>
                 <a:latin typeface="Malgun Gothic"/>
               </a:rPr>
-              <a:t>손상 방지</a:t>
+              <a:t>실행 전 예상</a:t>
             </a:r>
           </a:p>
         </p:txBody>
@@ -9001,7 +9001,7 @@
                 </a:solidFill>
                 <a:latin typeface="Malgun Gothic"/>
               </a:rPr>
-              <a:t>같은 task에서 이력을 이어갑니다. fixture 검증과 자연 발생 provider 실패 증거는 별개입니다.</a:t>
+              <a:t>대용량 실행 전 예상 시간·범위를 표시합니다. `large-estimate`로 task 없이 확인하세요. 예측은 승인이나 Gate C 증거가 아닙니다.</a:t>
             </a:r>
           </a:p>
         </p:txBody>

</xml_diff>